<commit_message>
Reply in native script for regional languages; refresh eval numbers
Language: the orchestrator now replies in each language's NATIVE script even
when the user typed romanised (Tamil -> Tamil script, Malayalam -> Malayalam,
Punjabi -> Gurmukhi, Hindi -> Devanagari), instead of drifting into thin
romanised text or English. Verified in-process for Tamil/Malayalam/Punjabi/Hindi.

Docs: refresh the README Evaluation section and the pitch deck with the latest
adversarial run against the live deployment - 452/458 (99%) overall, 100% on
injection and clinical safety, 0 injection attacks landed, and 0 server errors /
0 timeouts / 0 DB-lock errors across 1,086 requests (0.93s cold start, warm
reads ~1s p50). The deck's refinement slide now leads with Record Doctor Visit.
</commit_message>
<xml_diff>
--- a/docs/withcare.pptx
+++ b/docs/withcare.pptx
@@ -212,22 +212,22 @@
                 <c:ptCount val="8"/>
                 <c:lvl>
                   <c:pt idx="0">
-                    <c:v>Routing</c:v>
+                    <c:v>Injection</c:v>
                   </c:pt>
                   <c:pt idx="1">
                     <c:v>Clinical</c:v>
                   </c:pt>
                   <c:pt idx="2">
-                    <c:v>Injection</c:v>
+                    <c:v>ML-safety</c:v>
                   </c:pt>
                   <c:pt idx="3">
                     <c:v>Grounding</c:v>
                   </c:pt>
                   <c:pt idx="4">
-                    <c:v>RAG</c:v>
+                    <c:v>Constraints</c:v>
                   </c:pt>
                   <c:pt idx="5">
-                    <c:v>Voice</c:v>
+                    <c:v>Robustness</c:v>
                   </c:pt>
                   <c:pt idx="6">
                     <c:v>Multiling.</c:v>
@@ -255,7 +255,7 @@
                   <c:v>100</c:v>
                 </c:pt>
                 <c:pt idx="3">
-                  <c:v>100</c:v>
+                  <c:v>98</c:v>
                 </c:pt>
                 <c:pt idx="4">
                   <c:v>100</c:v>
@@ -264,10 +264,10 @@
                   <c:v>100</c:v>
                 </c:pt>
                 <c:pt idx="6">
-                  <c:v>91</c:v>
+                  <c:v>85</c:v>
                 </c:pt>
                 <c:pt idx="7">
-                  <c:v>98</c:v>
+                  <c:v>99</c:v>
                 </c:pt>
               </c:numCache>
             </c:numRef>
@@ -2784,7 +2784,7 @@
                 <a:ea typeface="Calibri" pitchFamily="34" charset="-122"/>
                 <a:cs typeface="Calibri" pitchFamily="34" charset="-120"/>
               </a:rPr>
-              <a:t>98%</a:t>
+              <a:t>99%</a:t>
             </a:r>
             <a:endParaRPr lang="en-US" sz="2600" dirty="0"/>
           </a:p>
@@ -2823,7 +2823,7 @@
                 <a:ea typeface="Calibri" pitchFamily="34" charset="-122"/>
                 <a:cs typeface="Calibri" pitchFamily="34" charset="-120"/>
               </a:rPr>
-              <a:t>on 152 tests</a:t>
+              <a:t>on 458 tests</a:t>
             </a:r>
             <a:endParaRPr lang="en-US" sz="1100" dirty="0"/>
           </a:p>
@@ -4106,7 +4106,7 @@
             </a:avLst>
           </a:prstGeom>
           <a:solidFill>
-            <a:srgbClr val="E8F0FE"/>
+            <a:srgbClr val="E1F3F6"/>
           </a:solidFill>
           <a:ln/>
         </p:spPr>
@@ -4138,13 +4138,13 @@
             <a:r>
               <a:rPr lang="en-US" sz="1508" dirty="0">
                 <a:solidFill>
-                  <a:srgbClr val="1A73E8"/>
-                </a:solidFill>
-                <a:latin typeface="Calibri" pitchFamily="34" charset="0"/>
-                <a:ea typeface="Calibri" pitchFamily="34" charset="-122"/>
-                <a:cs typeface="Calibri" pitchFamily="34" charset="-120"/>
-              </a:rPr>
-              <a:t>🗓️</a:t>
+                  <a:srgbClr val="0E8FA3"/>
+                </a:solidFill>
+                <a:latin typeface="Calibri" pitchFamily="34" charset="0"/>
+                <a:ea typeface="Calibri" pitchFamily="34" charset="-122"/>
+                <a:cs typeface="Calibri" pitchFamily="34" charset="-120"/>
+              </a:rPr>
+              <a:t>🩺</a:t>
             </a:r>
             <a:endParaRPr lang="en-US" sz="1508" dirty="0"/>
           </a:p>
@@ -4183,7 +4183,7 @@
                 <a:ea typeface="Calibri" pitchFamily="34" charset="-122"/>
                 <a:cs typeface="Calibri" pitchFamily="34" charset="-120"/>
               </a:rPr>
-              <a:t>Routines</a:t>
+              <a:t>Record Doctor Visit</a:t>
             </a:r>
             <a:endParaRPr lang="en-US" sz="1500" dirty="0"/>
           </a:p>
@@ -4225,7 +4225,7 @@
                 <a:ea typeface="Calibri" pitchFamily="34" charset="-122"/>
                 <a:cs typeface="Calibri" pitchFamily="34" charset="-120"/>
               </a:rPr>
-              <a:t>Workout, diet, skincare, check-ups — manual or Gemini-drafted, with reminders.</a:t>
+              <a:t>Gemini Live listens to the consultation and saves the meds, diet &amp; follow-up to your records.</a:t>
             </a:r>
             <a:endParaRPr lang="en-US" sz="1150" dirty="0"/>
           </a:p>
@@ -4282,7 +4282,7 @@
             </a:avLst>
           </a:prstGeom>
           <a:solidFill>
-            <a:srgbClr val="FCE8E6"/>
+            <a:srgbClr val="E8F0FE"/>
           </a:solidFill>
           <a:ln/>
         </p:spPr>
@@ -4314,13 +4314,13 @@
             <a:r>
               <a:rPr lang="en-US" sz="1508" dirty="0">
                 <a:solidFill>
-                  <a:srgbClr val="EA4335"/>
-                </a:solidFill>
-                <a:latin typeface="Calibri" pitchFamily="34" charset="0"/>
-                <a:ea typeface="Calibri" pitchFamily="34" charset="-122"/>
-                <a:cs typeface="Calibri" pitchFamily="34" charset="-120"/>
-              </a:rPr>
-              <a:t>💊</a:t>
+                  <a:srgbClr val="1A73E8"/>
+                </a:solidFill>
+                <a:latin typeface="Calibri" pitchFamily="34" charset="0"/>
+                <a:ea typeface="Calibri" pitchFamily="34" charset="-122"/>
+                <a:cs typeface="Calibri" pitchFamily="34" charset="-120"/>
+              </a:rPr>
+              <a:t>🗓️</a:t>
             </a:r>
             <a:endParaRPr lang="en-US" sz="1508" dirty="0"/>
           </a:p>
@@ -4359,7 +4359,7 @@
                 <a:ea typeface="Calibri" pitchFamily="34" charset="-122"/>
                 <a:cs typeface="Calibri" pitchFamily="34" charset="-120"/>
               </a:rPr>
-              <a:t>Medications</a:t>
+              <a:t>Routines</a:t>
             </a:r>
             <a:endParaRPr lang="en-US" sz="1500" dirty="0"/>
           </a:p>
@@ -4401,7 +4401,7 @@
                 <a:ea typeface="Calibri" pitchFamily="34" charset="-122"/>
                 <a:cs typeface="Calibri" pitchFamily="34" charset="-120"/>
               </a:rPr>
-              <a:t>Dose reminders, supply tracking, and a Gmail refill alert before they run out.</a:t>
+              <a:t>Workout, diet, skincare, check-ups — manual or Gemini-drafted, with reminders.</a:t>
             </a:r>
             <a:endParaRPr lang="en-US" sz="1150" dirty="0"/>
           </a:p>
@@ -4458,7 +4458,7 @@
             </a:avLst>
           </a:prstGeom>
           <a:solidFill>
-            <a:srgbClr val="E6F4EA"/>
+            <a:srgbClr val="FCE8E6"/>
           </a:solidFill>
           <a:ln/>
         </p:spPr>
@@ -4490,13 +4490,13 @@
             <a:r>
               <a:rPr lang="en-US" sz="1508" dirty="0">
                 <a:solidFill>
-                  <a:srgbClr val="34A853"/>
-                </a:solidFill>
-                <a:latin typeface="Calibri" pitchFamily="34" charset="0"/>
-                <a:ea typeface="Calibri" pitchFamily="34" charset="-122"/>
-                <a:cs typeface="Calibri" pitchFamily="34" charset="-120"/>
-              </a:rPr>
-              <a:t>📈</a:t>
+                  <a:srgbClr val="EA4335"/>
+                </a:solidFill>
+                <a:latin typeface="Calibri" pitchFamily="34" charset="0"/>
+                <a:ea typeface="Calibri" pitchFamily="34" charset="-122"/>
+                <a:cs typeface="Calibri" pitchFamily="34" charset="-120"/>
+              </a:rPr>
+              <a:t>💊</a:t>
             </a:r>
             <a:endParaRPr lang="en-US" sz="1508" dirty="0"/>
           </a:p>
@@ -4535,7 +4535,7 @@
                 <a:ea typeface="Calibri" pitchFamily="34" charset="-122"/>
                 <a:cs typeface="Calibri" pitchFamily="34" charset="-120"/>
               </a:rPr>
-              <a:t>Vitals + trends</a:t>
+              <a:t>Medications</a:t>
             </a:r>
             <a:endParaRPr lang="en-US" sz="1500" dirty="0"/>
           </a:p>
@@ -4577,7 +4577,7 @@
                 <a:ea typeface="Calibri" pitchFamily="34" charset="-122"/>
                 <a:cs typeface="Calibri" pitchFamily="34" charset="-120"/>
               </a:rPr>
-              <a:t>Log blood sugar, BP, weight, SpO₂ — see the trend move.</a:t>
+              <a:t>Dose reminders, supply tracking, and a Gmail refill alert before they run out.</a:t>
             </a:r>
             <a:endParaRPr lang="en-US" sz="1150" dirty="0"/>
           </a:p>
@@ -4634,7 +4634,7 @@
             </a:avLst>
           </a:prstGeom>
           <a:solidFill>
-            <a:srgbClr val="FEF3D6"/>
+            <a:srgbClr val="E6F4EA"/>
           </a:solidFill>
           <a:ln/>
         </p:spPr>
@@ -4666,13 +4666,13 @@
             <a:r>
               <a:rPr lang="en-US" sz="1508" dirty="0">
                 <a:solidFill>
-                  <a:srgbClr val="F9AB00"/>
-                </a:solidFill>
-                <a:latin typeface="Calibri" pitchFamily="34" charset="0"/>
-                <a:ea typeface="Calibri" pitchFamily="34" charset="-122"/>
-                <a:cs typeface="Calibri" pitchFamily="34" charset="-120"/>
-              </a:rPr>
-              <a:t>🚨</a:t>
+                  <a:srgbClr val="34A853"/>
+                </a:solidFill>
+                <a:latin typeface="Calibri" pitchFamily="34" charset="0"/>
+                <a:ea typeface="Calibri" pitchFamily="34" charset="-122"/>
+                <a:cs typeface="Calibri" pitchFamily="34" charset="-120"/>
+              </a:rPr>
+              <a:t>📈</a:t>
             </a:r>
             <a:endParaRPr lang="en-US" sz="1508" dirty="0"/>
           </a:p>
@@ -4711,7 +4711,7 @@
                 <a:ea typeface="Calibri" pitchFamily="34" charset="-122"/>
                 <a:cs typeface="Calibri" pitchFamily="34" charset="-120"/>
               </a:rPr>
-              <a:t>Emergency / SOS</a:t>
+              <a:t>Vitals + trends</a:t>
             </a:r>
             <a:endParaRPr lang="en-US" sz="1500" dirty="0"/>
           </a:p>
@@ -4753,7 +4753,7 @@
                 <a:ea typeface="Calibri" pitchFamily="34" charset="-122"/>
                 <a:cs typeface="Calibri" pitchFamily="34" charset="-120"/>
               </a:rPr>
-              <a:t>One tap emails blood group, allergies &amp; medicines to family.</a:t>
+              <a:t>Log blood sugar, BP, weight, SpO₂ — see the trend move.</a:t>
             </a:r>
             <a:endParaRPr lang="en-US" sz="1150" dirty="0"/>
           </a:p>
@@ -4810,7 +4810,7 @@
             </a:avLst>
           </a:prstGeom>
           <a:solidFill>
-            <a:srgbClr val="E1F3F6"/>
+            <a:srgbClr val="FEF3D6"/>
           </a:solidFill>
           <a:ln/>
         </p:spPr>
@@ -4842,13 +4842,13 @@
             <a:r>
               <a:rPr lang="en-US" sz="1508" dirty="0">
                 <a:solidFill>
-                  <a:srgbClr val="0E8FA3"/>
-                </a:solidFill>
-                <a:latin typeface="Calibri" pitchFamily="34" charset="0"/>
-                <a:ea typeface="Calibri" pitchFamily="34" charset="-122"/>
-                <a:cs typeface="Calibri" pitchFamily="34" charset="-120"/>
-              </a:rPr>
-              <a:t>🎙️</a:t>
+                  <a:srgbClr val="F9AB00"/>
+                </a:solidFill>
+                <a:latin typeface="Calibri" pitchFamily="34" charset="0"/>
+                <a:ea typeface="Calibri" pitchFamily="34" charset="-122"/>
+                <a:cs typeface="Calibri" pitchFamily="34" charset="-120"/>
+              </a:rPr>
+              <a:t>🚨</a:t>
             </a:r>
             <a:endParaRPr lang="en-US" sz="1508" dirty="0"/>
           </a:p>
@@ -4887,7 +4887,7 @@
                 <a:ea typeface="Calibri" pitchFamily="34" charset="-122"/>
                 <a:cs typeface="Calibri" pitchFamily="34" charset="-120"/>
               </a:rPr>
-              <a:t>Voice input</a:t>
+              <a:t>Emergency / SOS</a:t>
             </a:r>
             <a:endParaRPr lang="en-US" sz="1500" dirty="0"/>
           </a:p>
@@ -4929,7 +4929,7 @@
                 <a:ea typeface="Calibri" pitchFamily="34" charset="-122"/>
                 <a:cs typeface="Calibri" pitchFamily="34" charset="-120"/>
               </a:rPr>
-              <a:t>Speak instead of type — transcribed in 11 languages.</a:t>
+              <a:t>One tap emails blood group, allergies &amp; medicines to family.</a:t>
             </a:r>
             <a:endParaRPr lang="en-US" sz="1150" dirty="0"/>
           </a:p>
@@ -5063,7 +5063,7 @@
                 <a:ea typeface="Calibri" pitchFamily="34" charset="-122"/>
                 <a:cs typeface="Calibri" pitchFamily="34" charset="-120"/>
               </a:rPr>
-              <a:t>Gemini Live</a:t>
+              <a:t>Voice + Gemini Live</a:t>
             </a:r>
             <a:endParaRPr lang="en-US" sz="1500" dirty="0"/>
           </a:p>
@@ -5105,7 +5105,7 @@
                 <a:ea typeface="Calibri" pitchFamily="34" charset="-122"/>
                 <a:cs typeface="Calibri" pitchFamily="34" charset="-120"/>
               </a:rPr>
-              <a:t>A real hands-free spoken conversation, native audio.</a:t>
+              <a:t>Speak or hold a live hands-free conversation — native audio, 11 languages.</a:t>
             </a:r>
             <a:endParaRPr lang="en-US" sz="1150" dirty="0"/>
           </a:p>
@@ -5192,7 +5192,7 @@
                 <a:ea typeface="Calibri" pitchFamily="34" charset="-122"/>
                 <a:cs typeface="Calibri" pitchFamily="34" charset="-120"/>
               </a:rPr>
-              <a:t>language matching 7/11 → 11/11 · a false-completion guard (can't fake a booking) · a grounding rule (won't invent schemes).</a:t>
+              <a:t>regional languages now reply in native script · a false-completion guard (can't fake a booking) · a grounding rule (won't invent schemes).</a:t>
             </a:r>
             <a:endParaRPr lang="en-US" sz="1250" dirty="0"/>
           </a:p>
@@ -5474,7 +5474,7 @@
                 <a:ea typeface="Calibri" pitchFamily="34" charset="-122"/>
                 <a:cs typeface="Calibri" pitchFamily="34" charset="-120"/>
               </a:rPr>
-              <a:t>149/152</a:t>
+              <a:t>452/458</a:t>
             </a:r>
             <a:endParaRPr lang="en-US" sz="3000" dirty="0"/>
           </a:p>
@@ -5586,7 +5586,7 @@
                 <a:ea typeface="Calibri" pitchFamily="34" charset="-122"/>
                 <a:cs typeface="Calibri" pitchFamily="34" charset="-120"/>
               </a:rPr>
-              <a:t>0.3s</a:t>
+              <a:t>100%</a:t>
             </a:r>
             <a:endParaRPr lang="en-US" sz="3000" dirty="0"/>
           </a:p>
@@ -5625,7 +5625,7 @@
                 <a:ea typeface="Calibri" pitchFamily="34" charset="-122"/>
                 <a:cs typeface="Calibri" pitchFamily="34" charset="-120"/>
               </a:rPr>
-              <a:t>to refuse unsafe asks</a:t>
+              <a:t>on injection &amp; clinical</a:t>
             </a:r>
             <a:endParaRPr lang="en-US" sz="1150" dirty="0"/>
           </a:p>
@@ -5698,7 +5698,7 @@
                 <a:ea typeface="Calibri" pitchFamily="34" charset="-122"/>
                 <a:cs typeface="Calibri" pitchFamily="34" charset="-120"/>
               </a:rPr>
-              <a:t>0 / 3</a:t>
+              <a:t>0 / 159</a:t>
             </a:r>
             <a:endParaRPr lang="en-US" sz="3000" dirty="0"/>
           </a:p>
@@ -5737,7 +5737,7 @@
                 <a:ea typeface="Calibri" pitchFamily="34" charset="-122"/>
                 <a:cs typeface="Calibri" pitchFamily="34" charset="-120"/>
               </a:rPr>
-              <a:t>prompt injections land</a:t>
+              <a:t>injection attacks land</a:t>
             </a:r>
             <a:endParaRPr lang="en-US" sz="1150" dirty="0"/>
           </a:p>
@@ -5810,7 +5810,7 @@
                 <a:ea typeface="Calibri" pitchFamily="34" charset="-122"/>
                 <a:cs typeface="Calibri" pitchFamily="34" charset="-120"/>
               </a:rPr>
-              <a:t>99.9%</a:t>
+              <a:t>0 err</a:t>
             </a:r>
             <a:endParaRPr lang="en-US" sz="3000" dirty="0"/>
           </a:p>
@@ -5849,7 +5849,7 @@
                 <a:ea typeface="Calibri" pitchFamily="34" charset="-122"/>
                 <a:cs typeface="Calibri" pitchFamily="34" charset="-120"/>
               </a:rPr>
-              <a:t>of 808 load requests</a:t>
+              <a:t>in 1,086 requests</a:t>
             </a:r>
             <a:endParaRPr lang="en-US" sz="1150" dirty="0"/>
           </a:p>
@@ -5938,7 +5938,7 @@
                 <a:ea typeface="Calibri" pitchFamily="34" charset="-122"/>
                 <a:cs typeface="Calibri" pitchFamily="34" charset="-120"/>
               </a:rPr>
-              <a:t>The eval caught 2 real defects — both fixed</a:t>
+              <a:t>The eval caught 3 real defects — all fixed</a:t>
             </a:r>
             <a:endParaRPr lang="en-US" sz="1300" dirty="0"/>
           </a:p>
@@ -6298,7 +6298,7 @@
                 <a:ea typeface="Calibri" pitchFamily="34" charset="-122"/>
                 <a:cs typeface="Calibri" pitchFamily="34" charset="-120"/>
               </a:rPr>
-              <a:t>Non-English answered in English</a:t>
+              <a:t>Regional replies left romanised</a:t>
             </a:r>
             <a:endParaRPr lang="en-US" sz="1100" dirty="0"/>
           </a:p>
@@ -6337,7 +6337,7 @@
                 <a:ea typeface="Calibri" pitchFamily="34" charset="-122"/>
                 <a:cs typeface="Calibri" pitchFamily="34" charset="-120"/>
               </a:rPr>
-              <a:t>4/11</a:t>
+              <a:t>5/33</a:t>
             </a:r>
             <a:endParaRPr lang="en-US" sz="1200" dirty="0"/>
           </a:p>
@@ -6415,7 +6415,7 @@
                 <a:ea typeface="Calibri" pitchFamily="34" charset="-122"/>
                 <a:cs typeface="Calibri" pitchFamily="34" charset="-120"/>
               </a:rPr>
-              <a:t>0/11</a:t>
+              <a:t>native</a:t>
             </a:r>
             <a:endParaRPr lang="en-US" sz="1200" dirty="0"/>
           </a:p>
@@ -6430,7 +6430,7 @@
         <p:spPr>
           <a:xfrm>
             <a:off x="7406640" y="5715000"/>
-            <a:ext cx="4114800" cy="320040"/>
+            <a:ext cx="4297680" cy="320040"/>
           </a:xfrm>
           <a:prstGeom prst="rect">
             <a:avLst/>
@@ -6446,7 +6446,7 @@
               <a:buNone/>
             </a:pPr>
             <a:r>
-              <a:rPr lang="en-US" sz="1050" i="1" dirty="0">
+              <a:rPr lang="en-US" sz="1000" i="1" dirty="0">
                 <a:solidFill>
                   <a:srgbClr val="80868B"/>
                 </a:solidFill>
@@ -6454,9 +6454,9 @@
                 <a:ea typeface="Calibri" pitchFamily="34" charset="-122"/>
                 <a:cs typeface="Calibri" pitchFamily="34" charset="-120"/>
               </a:rPr>
-              <a:t>808 requests · 40 profiles · 0 timeouts · 0 DB-lock errors</a:t>
-            </a:r>
-            <a:endParaRPr lang="en-US" sz="1050" dirty="0"/>
+              <a:t>1,086 requests · 8 tenants · 0 timeouts · 0 DB-lock errors · 0.93s cold start</a:t>
+            </a:r>
+            <a:endParaRPr lang="en-US" sz="1000" dirty="0"/>
           </a:p>
         </p:txBody>
       </p:sp>

</xml_diff>

<commit_message>
docs: add Temporal Memory to the pitch deck
Update the refinement slide so Temporal Memory leads as the flagship upgrade
(vital trends, medicine adherence, weekly reports) and Medications notes the
one-tap adherence check-off; fold the old standalone "Vitals + trends" card in.
Update the architecture slide's memory box to the two-tier model (Knowledge
Graph + Temporal Memory + RAG). Eval slide already carries the latest numbers.
</commit_message>
<xml_diff>
--- a/docs/withcare.pptx
+++ b/docs/withcare.pptx
@@ -4106,7 +4106,7 @@
             </a:avLst>
           </a:prstGeom>
           <a:solidFill>
-            <a:srgbClr val="E1F3F6"/>
+            <a:srgbClr val="E6F4EA"/>
           </a:solidFill>
           <a:ln/>
         </p:spPr>
@@ -4138,13 +4138,13 @@
             <a:r>
               <a:rPr lang="en-US" sz="1508" dirty="0">
                 <a:solidFill>
-                  <a:srgbClr val="0E8FA3"/>
-                </a:solidFill>
-                <a:latin typeface="Calibri" pitchFamily="34" charset="0"/>
-                <a:ea typeface="Calibri" pitchFamily="34" charset="-122"/>
-                <a:cs typeface="Calibri" pitchFamily="34" charset="-120"/>
-              </a:rPr>
-              <a:t>🩺</a:t>
+                  <a:srgbClr val="34A853"/>
+                </a:solidFill>
+                <a:latin typeface="Calibri" pitchFamily="34" charset="0"/>
+                <a:ea typeface="Calibri" pitchFamily="34" charset="-122"/>
+                <a:cs typeface="Calibri" pitchFamily="34" charset="-120"/>
+              </a:rPr>
+              <a:t>📈</a:t>
             </a:r>
             <a:endParaRPr lang="en-US" sz="1508" dirty="0"/>
           </a:p>
@@ -4183,7 +4183,7 @@
                 <a:ea typeface="Calibri" pitchFamily="34" charset="-122"/>
                 <a:cs typeface="Calibri" pitchFamily="34" charset="-120"/>
               </a:rPr>
-              <a:t>Record Doctor Visit</a:t>
+              <a:t>Temporal Memory</a:t>
             </a:r>
             <a:endParaRPr lang="en-US" sz="1500" dirty="0"/>
           </a:p>
@@ -4225,7 +4225,7 @@
                 <a:ea typeface="Calibri" pitchFamily="34" charset="-122"/>
                 <a:cs typeface="Calibri" pitchFamily="34" charset="-120"/>
               </a:rPr>
-              <a:t>Gemini Live listens to the consultation and saves the meds, diet &amp; follow-up to your records.</a:t>
+              <a:t>Health tracked over time: vital trends, medicine adherence &amp; weekly reports — the trajectory, not just today's number.</a:t>
             </a:r>
             <a:endParaRPr lang="en-US" sz="1150" dirty="0"/>
           </a:p>
@@ -4282,7 +4282,7 @@
             </a:avLst>
           </a:prstGeom>
           <a:solidFill>
-            <a:srgbClr val="E8F0FE"/>
+            <a:srgbClr val="E1F3F6"/>
           </a:solidFill>
           <a:ln/>
         </p:spPr>
@@ -4314,13 +4314,13 @@
             <a:r>
               <a:rPr lang="en-US" sz="1508" dirty="0">
                 <a:solidFill>
-                  <a:srgbClr val="1A73E8"/>
-                </a:solidFill>
-                <a:latin typeface="Calibri" pitchFamily="34" charset="0"/>
-                <a:ea typeface="Calibri" pitchFamily="34" charset="-122"/>
-                <a:cs typeface="Calibri" pitchFamily="34" charset="-120"/>
-              </a:rPr>
-              <a:t>🗓️</a:t>
+                  <a:srgbClr val="0E8FA3"/>
+                </a:solidFill>
+                <a:latin typeface="Calibri" pitchFamily="34" charset="0"/>
+                <a:ea typeface="Calibri" pitchFamily="34" charset="-122"/>
+                <a:cs typeface="Calibri" pitchFamily="34" charset="-120"/>
+              </a:rPr>
+              <a:t>🩺</a:t>
             </a:r>
             <a:endParaRPr lang="en-US" sz="1508" dirty="0"/>
           </a:p>
@@ -4359,7 +4359,7 @@
                 <a:ea typeface="Calibri" pitchFamily="34" charset="-122"/>
                 <a:cs typeface="Calibri" pitchFamily="34" charset="-120"/>
               </a:rPr>
-              <a:t>Routines</a:t>
+              <a:t>Record Doctor Visit</a:t>
             </a:r>
             <a:endParaRPr lang="en-US" sz="1500" dirty="0"/>
           </a:p>
@@ -4401,7 +4401,7 @@
                 <a:ea typeface="Calibri" pitchFamily="34" charset="-122"/>
                 <a:cs typeface="Calibri" pitchFamily="34" charset="-120"/>
               </a:rPr>
-              <a:t>Workout, diet, skincare, check-ups — manual or Gemini-drafted, with reminders.</a:t>
+              <a:t>Gemini Live listens to the consultation and saves the meds, diet &amp; follow-up to your records.</a:t>
             </a:r>
             <a:endParaRPr lang="en-US" sz="1150" dirty="0"/>
           </a:p>
@@ -4458,7 +4458,7 @@
             </a:avLst>
           </a:prstGeom>
           <a:solidFill>
-            <a:srgbClr val="FCE8E6"/>
+            <a:srgbClr val="E8F0FE"/>
           </a:solidFill>
           <a:ln/>
         </p:spPr>
@@ -4490,13 +4490,13 @@
             <a:r>
               <a:rPr lang="en-US" sz="1508" dirty="0">
                 <a:solidFill>
-                  <a:srgbClr val="EA4335"/>
-                </a:solidFill>
-                <a:latin typeface="Calibri" pitchFamily="34" charset="0"/>
-                <a:ea typeface="Calibri" pitchFamily="34" charset="-122"/>
-                <a:cs typeface="Calibri" pitchFamily="34" charset="-120"/>
-              </a:rPr>
-              <a:t>💊</a:t>
+                  <a:srgbClr val="1A73E8"/>
+                </a:solidFill>
+                <a:latin typeface="Calibri" pitchFamily="34" charset="0"/>
+                <a:ea typeface="Calibri" pitchFamily="34" charset="-122"/>
+                <a:cs typeface="Calibri" pitchFamily="34" charset="-120"/>
+              </a:rPr>
+              <a:t>🗓️</a:t>
             </a:r>
             <a:endParaRPr lang="en-US" sz="1508" dirty="0"/>
           </a:p>
@@ -4535,7 +4535,7 @@
                 <a:ea typeface="Calibri" pitchFamily="34" charset="-122"/>
                 <a:cs typeface="Calibri" pitchFamily="34" charset="-120"/>
               </a:rPr>
-              <a:t>Medications</a:t>
+              <a:t>Routines</a:t>
             </a:r>
             <a:endParaRPr lang="en-US" sz="1500" dirty="0"/>
           </a:p>
@@ -4577,7 +4577,7 @@
                 <a:ea typeface="Calibri" pitchFamily="34" charset="-122"/>
                 <a:cs typeface="Calibri" pitchFamily="34" charset="-120"/>
               </a:rPr>
-              <a:t>Dose reminders, supply tracking, and a Gmail refill alert before they run out.</a:t>
+              <a:t>Workout, diet, skincare, check-ups — manual or Gemini-drafted, with reminders.</a:t>
             </a:r>
             <a:endParaRPr lang="en-US" sz="1150" dirty="0"/>
           </a:p>
@@ -4634,7 +4634,7 @@
             </a:avLst>
           </a:prstGeom>
           <a:solidFill>
-            <a:srgbClr val="E6F4EA"/>
+            <a:srgbClr val="FCE8E6"/>
           </a:solidFill>
           <a:ln/>
         </p:spPr>
@@ -4666,13 +4666,13 @@
             <a:r>
               <a:rPr lang="en-US" sz="1508" dirty="0">
                 <a:solidFill>
-                  <a:srgbClr val="34A853"/>
-                </a:solidFill>
-                <a:latin typeface="Calibri" pitchFamily="34" charset="0"/>
-                <a:ea typeface="Calibri" pitchFamily="34" charset="-122"/>
-                <a:cs typeface="Calibri" pitchFamily="34" charset="-120"/>
-              </a:rPr>
-              <a:t>📈</a:t>
+                  <a:srgbClr val="EA4335"/>
+                </a:solidFill>
+                <a:latin typeface="Calibri" pitchFamily="34" charset="0"/>
+                <a:ea typeface="Calibri" pitchFamily="34" charset="-122"/>
+                <a:cs typeface="Calibri" pitchFamily="34" charset="-120"/>
+              </a:rPr>
+              <a:t>💊</a:t>
             </a:r>
             <a:endParaRPr lang="en-US" sz="1508" dirty="0"/>
           </a:p>
@@ -4711,7 +4711,7 @@
                 <a:ea typeface="Calibri" pitchFamily="34" charset="-122"/>
                 <a:cs typeface="Calibri" pitchFamily="34" charset="-120"/>
               </a:rPr>
-              <a:t>Vitals + trends</a:t>
+              <a:t>Medications</a:t>
             </a:r>
             <a:endParaRPr lang="en-US" sz="1500" dirty="0"/>
           </a:p>
@@ -4753,7 +4753,7 @@
                 <a:ea typeface="Calibri" pitchFamily="34" charset="-122"/>
                 <a:cs typeface="Calibri" pitchFamily="34" charset="-120"/>
               </a:rPr>
-              <a:t>Log blood sugar, BP, weight, SpO₂ — see the trend move.</a:t>
+              <a:t>Dose reminders, supply tracking, a one-tap adherence check-off, and a Gmail refill alert.</a:t>
             </a:r>
             <a:endParaRPr lang="en-US" sz="1150" dirty="0"/>
           </a:p>
@@ -15286,7 +15286,7 @@
                 <a:ea typeface="Calibri" pitchFamily="34" charset="-122"/>
                 <a:cs typeface="Calibri" pitchFamily="34" charset="-120"/>
               </a:rPr>
-              <a:t>Memory + docs
+              <a:t>Two-tier memory
 </a:t>
             </a:r>
             <a:pPr algn="ctr" indent="0" marL="0">
@@ -15304,7 +15304,7 @@
                 <a:ea typeface="Calibri" pitchFamily="34" charset="-122"/>
                 <a:cs typeface="Calibri" pitchFamily="34" charset="-120"/>
               </a:rPr>
-              <a:t>Knowledge graph +</a:t>
+              <a:t>Knowledge graph + Temporal</a:t>
             </a:r>
             <a:endParaRPr lang="en-US" sz="1300" dirty="0"/>
           </a:p>
@@ -15324,7 +15324,7 @@
                 <a:ea typeface="Calibri" pitchFamily="34" charset="-122"/>
                 <a:cs typeface="Calibri" pitchFamily="34" charset="-120"/>
               </a:rPr>
-              <a:t>RAG over user files</a:t>
+              <a:t>Memory + RAG over docs</a:t>
             </a:r>
             <a:endParaRPr lang="en-US" sz="1300" dirty="0"/>
           </a:p>

</xml_diff>